<commit_message>
update abstract & add slides
</commit_message>
<xml_diff>
--- a/docs/2026-Beckman-Research.pptx
+++ b/docs/2026-Beckman-Research.pptx
@@ -2375,7 +2375,7 @@
         </p:spPr>
         <p:txBody>
           <a:bodyPr>
-            <a:normAutofit fontScale="85000" lnSpcReduction="20000"/>
+            <a:normAutofit fontScale="92500" lnSpcReduction="20000"/>
           </a:bodyPr>
           <a:lstStyle/>
           <a:p>
@@ -2517,47 +2517,9 @@
             </a:endParaRPr>
           </a:p>
           <a:p>
-            <a:endParaRPr lang="en-US" sz="1200" dirty="0">
-              <a:solidFill>
-                <a:srgbClr val="333333"/>
-              </a:solidFill>
-              <a:latin typeface="Helvetica Neue" panose="02000503000000020004" pitchFamily="2" charset="0"/>
-            </a:endParaRPr>
-          </a:p>
-          <a:p>
-            <a:endParaRPr lang="en-US" sz="1200" dirty="0">
-              <a:solidFill>
-                <a:srgbClr val="333333"/>
-              </a:solidFill>
-              <a:latin typeface="Helvetica Neue" panose="02000503000000020004" pitchFamily="2" charset="0"/>
-            </a:endParaRPr>
-          </a:p>
-          <a:p>
-            <a:endParaRPr lang="en-US" sz="1200" dirty="0">
-              <a:solidFill>
-                <a:srgbClr val="333333"/>
-              </a:solidFill>
-              <a:latin typeface="Helvetica Neue" panose="02000503000000020004" pitchFamily="2" charset="0"/>
-            </a:endParaRPr>
-          </a:p>
-          <a:p>
-            <a:pPr lvl="1"/>
-            <a:endParaRPr lang="en-US" sz="800" dirty="0">
-              <a:solidFill>
-                <a:srgbClr val="333333"/>
-              </a:solidFill>
-              <a:latin typeface="Helvetica Neue" panose="02000503000000020004" pitchFamily="2" charset="0"/>
-            </a:endParaRPr>
-          </a:p>
-          <a:p>
-            <a:endParaRPr lang="en-US" sz="1200" dirty="0">
-              <a:solidFill>
-                <a:srgbClr val="333333"/>
-              </a:solidFill>
-              <a:latin typeface="Helvetica Neue" panose="02000503000000020004" pitchFamily="2" charset="0"/>
-            </a:endParaRPr>
-          </a:p>
-          <a:p>
+            <a:pPr marL="0" indent="0">
+              <a:buNone/>
+            </a:pPr>
             <a:endParaRPr lang="en-US" sz="1200" dirty="0">
               <a:solidFill>
                 <a:srgbClr val="333333"/>
@@ -2597,6 +2559,79 @@
             </a:endParaRPr>
           </a:p>
           <a:p>
+            <a:pPr marL="0" indent="0">
+              <a:lnSpc>
+                <a:spcPct val="120000"/>
+              </a:lnSpc>
+              <a:spcBef>
+                <a:spcPts val="100"/>
+              </a:spcBef>
+              <a:buNone/>
+            </a:pPr>
+            <a:endParaRPr lang="en-US" sz="900" dirty="0">
+              <a:solidFill>
+                <a:srgbClr val="333333"/>
+              </a:solidFill>
+              <a:latin typeface="Helvetica Neue" panose="02000503000000020004" pitchFamily="2" charset="0"/>
+            </a:endParaRPr>
+          </a:p>
+          <a:p>
+            <a:pPr marL="0" indent="0">
+              <a:lnSpc>
+                <a:spcPct val="120000"/>
+              </a:lnSpc>
+              <a:spcBef>
+                <a:spcPts val="100"/>
+              </a:spcBef>
+              <a:buNone/>
+            </a:pPr>
+            <a:r>
+              <a:rPr lang="en-US" sz="900" dirty="0">
+                <a:solidFill>
+                  <a:srgbClr val="333333"/>
+                </a:solidFill>
+                <a:latin typeface="Helvetica Neue" panose="02000503000000020004" pitchFamily="2" charset="0"/>
+              </a:rPr>
+              <a:t>Beckman, Burke, </a:t>
+            </a:r>
+            <a:r>
+              <a:rPr lang="en-US" sz="900" dirty="0" err="1">
+                <a:solidFill>
+                  <a:srgbClr val="333333"/>
+                </a:solidFill>
+                <a:latin typeface="Helvetica Neue" panose="02000503000000020004" pitchFamily="2" charset="0"/>
+              </a:rPr>
+              <a:t>Fiochetta</a:t>
+            </a:r>
+            <a:r>
+              <a:rPr lang="en-US" sz="900" dirty="0">
+                <a:solidFill>
+                  <a:srgbClr val="333333"/>
+                </a:solidFill>
+                <a:latin typeface="Helvetica Neue" panose="02000503000000020004" pitchFamily="2" charset="0"/>
+              </a:rPr>
+              <a:t>, Fry, Susan Lloyd, Patterson, Elle Tang (in review). Developing Consistency Among Undergraduate Graders Scoring Open-Ended Statistics Tasks. Preprint URL: https://</a:t>
+            </a:r>
+            <a:r>
+              <a:rPr lang="en-US" sz="900" dirty="0" err="1">
+                <a:solidFill>
+                  <a:srgbClr val="333333"/>
+                </a:solidFill>
+                <a:latin typeface="Helvetica Neue" panose="02000503000000020004" pitchFamily="2" charset="0"/>
+              </a:rPr>
+              <a:t>arxiv.org</a:t>
+            </a:r>
+            <a:r>
+              <a:rPr lang="en-US" sz="900" dirty="0">
+                <a:solidFill>
+                  <a:srgbClr val="333333"/>
+                </a:solidFill>
+                <a:latin typeface="Helvetica Neue" panose="02000503000000020004" pitchFamily="2" charset="0"/>
+              </a:rPr>
+              <a:t>/abs/2410.18062</a:t>
+            </a:r>
+          </a:p>
+          <a:p>
             <a:pPr marL="0" indent="0" algn="l">
               <a:lnSpc>
                 <a:spcPct val="120000"/>
@@ -2623,12 +2658,78 @@
               </a:spcBef>
               <a:buNone/>
             </a:pPr>
-            <a:endParaRPr lang="en-US" sz="900" dirty="0">
-              <a:solidFill>
-                <a:srgbClr val="333333"/>
-              </a:solidFill>
-              <a:latin typeface="Helvetica Neue" panose="02000503000000020004" pitchFamily="2" charset="0"/>
-            </a:endParaRPr>
+            <a:r>
+              <a:rPr lang="en-US" sz="900">
+                <a:solidFill>
+                  <a:srgbClr val="333333"/>
+                </a:solidFill>
+                <a:latin typeface="Helvetica Neue" panose="02000503000000020004" pitchFamily="2" charset="0"/>
+              </a:rPr>
+              <a:t>Li, </a:t>
+            </a:r>
+            <a:r>
+              <a:rPr lang="en-US" sz="900" dirty="0">
+                <a:solidFill>
+                  <a:srgbClr val="333333"/>
+                </a:solidFill>
+                <a:latin typeface="Helvetica Neue" panose="02000503000000020004" pitchFamily="2" charset="0"/>
+              </a:rPr>
+              <a:t>Susan Lloyd, Beckman, &amp; </a:t>
+            </a:r>
+            <a:r>
+              <a:rPr lang="en-US" sz="900" dirty="0" err="1">
+                <a:solidFill>
+                  <a:srgbClr val="333333"/>
+                </a:solidFill>
+                <a:latin typeface="Helvetica Neue" panose="02000503000000020004" pitchFamily="2" charset="0"/>
+              </a:rPr>
+              <a:t>Passonneau</a:t>
+            </a:r>
+            <a:r>
+              <a:rPr lang="en-US" sz="900" dirty="0">
+                <a:solidFill>
+                  <a:srgbClr val="333333"/>
+                </a:solidFill>
+                <a:latin typeface="Helvetica Neue" panose="02000503000000020004" pitchFamily="2" charset="0"/>
+              </a:rPr>
+              <a:t> (2023). Answer-state Recurrent Relational Network (</a:t>
+            </a:r>
+            <a:r>
+              <a:rPr lang="en-US" sz="900" dirty="0" err="1">
+                <a:solidFill>
+                  <a:srgbClr val="333333"/>
+                </a:solidFill>
+                <a:latin typeface="Helvetica Neue" panose="02000503000000020004" pitchFamily="2" charset="0"/>
+              </a:rPr>
+              <a:t>AsRRN</a:t>
+            </a:r>
+            <a:r>
+              <a:rPr lang="en-US" sz="900" dirty="0">
+                <a:solidFill>
+                  <a:srgbClr val="333333"/>
+                </a:solidFill>
+                <a:latin typeface="Helvetica Neue" panose="02000503000000020004" pitchFamily="2" charset="0"/>
+              </a:rPr>
+              <a:t>) for Constructed Response Assessment and Feedback Grouping. </a:t>
+            </a:r>
+            <a:r>
+              <a:rPr lang="en-US" sz="900" i="1" dirty="0">
+                <a:solidFill>
+                  <a:srgbClr val="333333"/>
+                </a:solidFill>
+                <a:latin typeface="Helvetica Neue" panose="02000503000000020004" pitchFamily="2" charset="0"/>
+              </a:rPr>
+              <a:t>Findings of the Conference on Empirical Methods in Natural Language Processing (EMNLP) 2023</a:t>
+            </a:r>
+            <a:r>
+              <a:rPr lang="en-US" sz="900" dirty="0">
+                <a:solidFill>
+                  <a:srgbClr val="333333"/>
+                </a:solidFill>
+                <a:latin typeface="Helvetica Neue" panose="02000503000000020004" pitchFamily="2" charset="0"/>
+              </a:rPr>
+              <a:t> </a:t>
+            </a:r>
           </a:p>
           <a:p>
             <a:pPr marL="0" indent="0" algn="l">
@@ -2640,69 +2741,12 @@
               </a:spcBef>
               <a:buNone/>
             </a:pPr>
-            <a:r>
-              <a:rPr lang="en-US" sz="900" dirty="0">
-                <a:solidFill>
-                  <a:srgbClr val="333333"/>
-                </a:solidFill>
-                <a:latin typeface="Helvetica Neue" panose="02000503000000020004" pitchFamily="2" charset="0"/>
-              </a:rPr>
-              <a:t>Li, Z., Susan Lloyd, Beckman, &amp; </a:t>
-            </a:r>
-            <a:r>
-              <a:rPr lang="en-US" sz="900" dirty="0" err="1">
-                <a:solidFill>
-                  <a:srgbClr val="333333"/>
-                </a:solidFill>
-                <a:latin typeface="Helvetica Neue" panose="02000503000000020004" pitchFamily="2" charset="0"/>
-              </a:rPr>
-              <a:t>Passonneau</a:t>
-            </a:r>
-            <a:r>
-              <a:rPr lang="en-US" sz="900" dirty="0">
-                <a:solidFill>
-                  <a:srgbClr val="333333"/>
-                </a:solidFill>
-                <a:latin typeface="Helvetica Neue" panose="02000503000000020004" pitchFamily="2" charset="0"/>
-              </a:rPr>
-              <a:t> (2023). Answer-state Recurrent Relational Network (</a:t>
-            </a:r>
-            <a:r>
-              <a:rPr lang="en-US" sz="900" dirty="0" err="1">
-                <a:solidFill>
-                  <a:srgbClr val="333333"/>
-                </a:solidFill>
-                <a:latin typeface="Helvetica Neue" panose="02000503000000020004" pitchFamily="2" charset="0"/>
-              </a:rPr>
-              <a:t>AsRRN</a:t>
-            </a:r>
-            <a:r>
-              <a:rPr lang="en-US" sz="900" dirty="0">
-                <a:solidFill>
-                  <a:srgbClr val="333333"/>
-                </a:solidFill>
-                <a:latin typeface="Helvetica Neue" panose="02000503000000020004" pitchFamily="2" charset="0"/>
-              </a:rPr>
-              <a:t>) for Constructed Response Assessment and Feedback Grouping. </a:t>
-            </a:r>
-            <a:r>
-              <a:rPr lang="en-US" sz="900" i="1" dirty="0">
-                <a:solidFill>
-                  <a:srgbClr val="333333"/>
-                </a:solidFill>
-                <a:latin typeface="Helvetica Neue" panose="02000503000000020004" pitchFamily="2" charset="0"/>
-              </a:rPr>
-              <a:t>Findings of the Conference on Empirical Methods in Natural Language Processing (EMNLP) 2023</a:t>
-            </a:r>
-            <a:r>
-              <a:rPr lang="en-US" sz="900" dirty="0">
-                <a:solidFill>
-                  <a:srgbClr val="333333"/>
-                </a:solidFill>
-                <a:latin typeface="Helvetica Neue" panose="02000503000000020004" pitchFamily="2" charset="0"/>
-              </a:rPr>
-              <a:t> </a:t>
-            </a:r>
+            <a:endParaRPr lang="en-US" sz="900" dirty="0">
+              <a:solidFill>
+                <a:srgbClr val="333333"/>
+              </a:solidFill>
+              <a:latin typeface="Helvetica Neue" panose="02000503000000020004" pitchFamily="2" charset="0"/>
+            </a:endParaRPr>
           </a:p>
           <a:p>
             <a:pPr marL="0" indent="0" algn="l">
@@ -2714,12 +2758,56 @@
               </a:spcBef>
               <a:buNone/>
             </a:pPr>
-            <a:endParaRPr lang="en-US" sz="900" dirty="0">
-              <a:solidFill>
-                <a:srgbClr val="333333"/>
-              </a:solidFill>
-              <a:latin typeface="Helvetica Neue" panose="02000503000000020004" pitchFamily="2" charset="0"/>
-            </a:endParaRPr>
+            <a:r>
+              <a:rPr lang="en-US" sz="900" b="0" i="0" dirty="0">
+                <a:solidFill>
+                  <a:srgbClr val="333333"/>
+                </a:solidFill>
+                <a:effectLst/>
+                <a:latin typeface="Helvetica Neue" panose="02000503000000020004" pitchFamily="2" charset="0"/>
+              </a:rPr>
+              <a:t>Susan Lloyd, Beckman, Pearl, </a:t>
+            </a:r>
+            <a:r>
+              <a:rPr lang="en-US" sz="900" b="0" i="0" dirty="0" err="1">
+                <a:solidFill>
+                  <a:srgbClr val="333333"/>
+                </a:solidFill>
+                <a:effectLst/>
+                <a:latin typeface="Helvetica Neue" panose="02000503000000020004" pitchFamily="2" charset="0"/>
+              </a:rPr>
+              <a:t>Passonneau</a:t>
+            </a:r>
+            <a:r>
+              <a:rPr lang="en-US" sz="900" b="0" i="0" dirty="0">
+                <a:solidFill>
+                  <a:srgbClr val="333333"/>
+                </a:solidFill>
+                <a:effectLst/>
+                <a:latin typeface="Helvetica Neue" panose="02000503000000020004" pitchFamily="2" charset="0"/>
+              </a:rPr>
+              <a:t>, Li, &amp; Wang (2022). Foundations for AI-Assisted Formative Assessment Feedback for Short-Answer Tasks in Large-Enrollment Classes. In </a:t>
+            </a:r>
+            <a:r>
+              <a:rPr lang="en-US" sz="900" b="0" i="1" dirty="0">
+                <a:solidFill>
+                  <a:srgbClr val="333333"/>
+                </a:solidFill>
+                <a:effectLst/>
+                <a:latin typeface="Helvetica Neue" panose="02000503000000020004" pitchFamily="2" charset="0"/>
+              </a:rPr>
+              <a:t>Proceedings of the eleventh international conference on teaching statistics</a:t>
+            </a:r>
+            <a:r>
+              <a:rPr lang="en-US" sz="900" b="0" i="0" dirty="0">
+                <a:solidFill>
+                  <a:srgbClr val="333333"/>
+                </a:solidFill>
+                <a:effectLst/>
+                <a:latin typeface="Helvetica Neue" panose="02000503000000020004" pitchFamily="2" charset="0"/>
+              </a:rPr>
+              <a:t>. Rosario, Argentina.</a:t>
+            </a:r>
           </a:p>
           <a:p>
             <a:pPr marL="0" indent="0" algn="l">
@@ -2731,75 +2819,42 @@
               </a:spcBef>
               <a:buNone/>
             </a:pPr>
-            <a:r>
-              <a:rPr lang="en-US" sz="900" b="0" i="0" dirty="0">
-                <a:solidFill>
-                  <a:srgbClr val="333333"/>
-                </a:solidFill>
-                <a:effectLst/>
-                <a:latin typeface="Helvetica Neue" panose="02000503000000020004" pitchFamily="2" charset="0"/>
-              </a:rPr>
-              <a:t>Susan Lloyd, Beckman, Pearl, </a:t>
-            </a:r>
-            <a:r>
-              <a:rPr lang="en-US" sz="900" b="0" i="0" dirty="0" err="1">
-                <a:solidFill>
-                  <a:srgbClr val="333333"/>
-                </a:solidFill>
-                <a:effectLst/>
-                <a:latin typeface="Helvetica Neue" panose="02000503000000020004" pitchFamily="2" charset="0"/>
-              </a:rPr>
-              <a:t>Passonneau</a:t>
-            </a:r>
-            <a:r>
-              <a:rPr lang="en-US" sz="900" b="0" i="0" dirty="0">
-                <a:solidFill>
-                  <a:srgbClr val="333333"/>
-                </a:solidFill>
-                <a:effectLst/>
-                <a:latin typeface="Helvetica Neue" panose="02000503000000020004" pitchFamily="2" charset="0"/>
-              </a:rPr>
-              <a:t>, Li, &amp; Wang (2022). Foundations for AI-Assisted Formative Assessment Feedback for Short-Answer Tasks in Large-Enrollment Classes. In </a:t>
-            </a:r>
-            <a:r>
-              <a:rPr lang="en-US" sz="900" b="0" i="1" dirty="0">
-                <a:solidFill>
-                  <a:srgbClr val="333333"/>
-                </a:solidFill>
-                <a:effectLst/>
-                <a:latin typeface="Helvetica Neue" panose="02000503000000020004" pitchFamily="2" charset="0"/>
-              </a:rPr>
-              <a:t>Proceedings of the eleventh international conference on teaching statistics</a:t>
-            </a:r>
-            <a:r>
-              <a:rPr lang="en-US" sz="900" b="0" i="0" dirty="0">
-                <a:solidFill>
-                  <a:srgbClr val="333333"/>
-                </a:solidFill>
-                <a:effectLst/>
-                <a:latin typeface="Helvetica Neue" panose="02000503000000020004" pitchFamily="2" charset="0"/>
-              </a:rPr>
-              <a:t>. Rosario, Argentina.</a:t>
-            </a:r>
-          </a:p>
-          <a:p>
-            <a:pPr marL="0" indent="0" algn="l">
-              <a:buNone/>
-            </a:pPr>
-            <a:r>
-              <a:rPr lang="en-US" sz="1100" dirty="0">
-                <a:solidFill>
-                  <a:srgbClr val="333333"/>
-                </a:solidFill>
-                <a:latin typeface="Helvetica Neue" panose="02000503000000020004" pitchFamily="2" charset="0"/>
-              </a:rPr>
-              <a:t>           NSF Awards #2236150 (Project CLASSIFIES) &amp; # (MCA)</a:t>
-            </a:r>
-            <a:endParaRPr lang="en-US" sz="1300" b="0" i="0" dirty="0">
+            <a:endParaRPr lang="en-US" sz="900" b="0" i="0" dirty="0">
               <a:solidFill>
                 <a:srgbClr val="333333"/>
               </a:solidFill>
               <a:effectLst/>
+              <a:latin typeface="Helvetica Neue" panose="02000503000000020004" pitchFamily="2" charset="0"/>
+            </a:endParaRPr>
+          </a:p>
+          <a:p>
+            <a:pPr marL="0" indent="0">
+              <a:buNone/>
+            </a:pPr>
+            <a:r>
+              <a:rPr lang="en-US" sz="1100" dirty="0">
+                <a:solidFill>
+                  <a:srgbClr val="333333"/>
+                </a:solidFill>
+                <a:latin typeface="Helvetica Neue" panose="02000503000000020004" pitchFamily="2" charset="0"/>
+              </a:rPr>
+              <a:t>           NSF Awards 2236150 &amp; 2423026; Penn State CSRAI Seed Grant #025243</a:t>
+            </a:r>
+            <a:endParaRPr lang="en-US" sz="1300" dirty="0">
+              <a:solidFill>
+                <a:srgbClr val="333333"/>
+              </a:solidFill>
+              <a:latin typeface="Helvetica Neue" panose="02000503000000020004" pitchFamily="2" charset="0"/>
+            </a:endParaRPr>
+          </a:p>
+          <a:p>
+            <a:pPr marL="0" indent="0">
+              <a:buNone/>
+            </a:pPr>
+            <a:endParaRPr lang="en-US" sz="1100" dirty="0">
+              <a:solidFill>
+                <a:srgbClr val="333333"/>
+              </a:solidFill>
               <a:latin typeface="Helvetica Neue" panose="02000503000000020004" pitchFamily="2" charset="0"/>
             </a:endParaRPr>
           </a:p>
@@ -2819,7 +2874,7 @@
         </p:nvSpPr>
         <p:spPr>
           <a:xfrm>
-            <a:off x="5587368" y="5887855"/>
+            <a:off x="5659320" y="5621835"/>
             <a:ext cx="2542145" cy="646331"/>
           </a:xfrm>
           <a:prstGeom prst="rect">
@@ -2833,6 +2888,7 @@
           </a:bodyPr>
           <a:lstStyle/>
           <a:p>
+            <a:pPr algn="ctr"/>
             <a:r>
               <a:rPr lang="en-US" dirty="0">
                 <a:solidFill>
@@ -2844,24 +2900,22 @@
             </a:r>
           </a:p>
           <a:p>
-            <a:r>
-              <a:rPr lang="en-US">
+            <a:pPr algn="ctr"/>
+            <a:r>
+              <a:rPr lang="en-US" dirty="0" err="1">
                 <a:solidFill>
                   <a:srgbClr val="333333"/>
                 </a:solidFill>
                 <a:latin typeface="Helvetica Neue" panose="02000503000000020004" pitchFamily="2" charset="0"/>
               </a:rPr>
-              <a:t>mdbeckman</a:t>
-            </a:r>
-            <a:r>
-              <a:rPr lang="en-US" dirty="0">
-                <a:solidFill>
-                  <a:srgbClr val="333333"/>
-                </a:solidFill>
-                <a:latin typeface="Helvetica Neue" panose="02000503000000020004" pitchFamily="2" charset="0"/>
-              </a:rPr>
-              <a:t>.github.io</a:t>
-            </a:r>
+              <a:t>mdbeckman.github.io</a:t>
+            </a:r>
+            <a:endParaRPr lang="en-US" dirty="0">
+              <a:solidFill>
+                <a:srgbClr val="333333"/>
+              </a:solidFill>
+              <a:latin typeface="Helvetica Neue" panose="02000503000000020004" pitchFamily="2" charset="0"/>
+            </a:endParaRPr>
           </a:p>
         </p:txBody>
       </p:sp>
@@ -2882,7 +2936,7 @@
         <p:spPr>
           <a:xfrm>
             <a:off x="4910763" y="272204"/>
-            <a:ext cx="4135423" cy="5568836"/>
+            <a:ext cx="4135423" cy="5303096"/>
           </a:xfrm>
           <a:prstGeom prst="rect">
             <a:avLst/>
@@ -3230,7 +3284,7 @@
         </p:nvSpPr>
         <p:spPr>
           <a:xfrm>
-            <a:off x="9140776" y="4418834"/>
+            <a:off x="9140777" y="4641360"/>
             <a:ext cx="2796119" cy="1569660"/>
           </a:xfrm>
           <a:prstGeom prst="rect">
@@ -3377,10 +3431,10 @@
       </p:sp>
       <p:pic>
         <p:nvPicPr>
-          <p:cNvPr id="10" name="Picture 9" descr="A diagram of a software program&#10;&#10;Description automatically generated">
+          <p:cNvPr id="12" name="Picture 11" descr="A logo of a globe with a gold cogwheel&#10;&#10;Description automatically generated">
             <a:extLst>
               <a:ext uri="{FF2B5EF4-FFF2-40B4-BE49-F238E27FC236}">
-                <a16:creationId xmlns:a16="http://schemas.microsoft.com/office/drawing/2014/main" id="{A33F9D9B-D4B9-32A8-F0BF-9554A66C5330}"/>
+                <a16:creationId xmlns:a16="http://schemas.microsoft.com/office/drawing/2014/main" id="{68747CA0-270C-1B00-05B3-6C1055FF0774}"/>
               </a:ext>
             </a:extLst>
           </p:cNvPr>
@@ -3403,20 +3457,471 @@
         </p:blipFill>
         <p:spPr>
           <a:xfrm>
-            <a:off x="515339" y="1296034"/>
-            <a:ext cx="3991387" cy="2196840"/>
+            <a:off x="111301" y="6302870"/>
+            <a:ext cx="427382" cy="427382"/>
           </a:xfrm>
           <a:prstGeom prst="rect">
             <a:avLst/>
           </a:prstGeom>
         </p:spPr>
       </p:pic>
+      <p:sp>
+        <p:nvSpPr>
+          <p:cNvPr id="5" name="TextBox 4">
+            <a:extLst>
+              <a:ext uri="{FF2B5EF4-FFF2-40B4-BE49-F238E27FC236}">
+                <a16:creationId xmlns:a16="http://schemas.microsoft.com/office/drawing/2014/main" id="{BEC779EE-343C-5AD2-5686-9E9B963EF0BF}"/>
+              </a:ext>
+            </a:extLst>
+          </p:cNvPr>
+          <p:cNvSpPr txBox="1"/>
+          <p:nvPr/>
+        </p:nvSpPr>
+        <p:spPr>
+          <a:xfrm>
+            <a:off x="9140777" y="127748"/>
+            <a:ext cx="2939922" cy="4638193"/>
+          </a:xfrm>
+          <a:prstGeom prst="rect">
+            <a:avLst/>
+          </a:prstGeom>
+          <a:noFill/>
+        </p:spPr>
+        <p:txBody>
+          <a:bodyPr wrap="square" rtlCol="0">
+            <a:spAutoFit/>
+          </a:bodyPr>
+          <a:lstStyle/>
+          <a:p>
+            <a:r>
+              <a:rPr lang="en-US" sz="1900" b="1" dirty="0">
+                <a:solidFill>
+                  <a:schemeClr val="accent2"/>
+                </a:solidFill>
+              </a:rPr>
+              <a:t>Other Projects/Interests</a:t>
+            </a:r>
+          </a:p>
+          <a:p>
+            <a:pPr marL="171450" indent="-171450">
+              <a:lnSpc>
+                <a:spcPct val="90000"/>
+              </a:lnSpc>
+              <a:spcBef>
+                <a:spcPts val="1000"/>
+              </a:spcBef>
+              <a:buFont typeface="Arial" panose="020B0604020202020204" pitchFamily="34" charset="0"/>
+              <a:buChar char="•"/>
+            </a:pPr>
+            <a:r>
+              <a:rPr lang="en-US" sz="1250" dirty="0">
+                <a:solidFill>
+                  <a:srgbClr val="333333"/>
+                </a:solidFill>
+                <a:latin typeface="Helvetica Neue" panose="02000503000000020004" pitchFamily="2" charset="0"/>
+              </a:rPr>
+              <a:t>Educational Assessment</a:t>
+            </a:r>
+          </a:p>
+          <a:p>
+            <a:pPr>
+              <a:lnSpc>
+                <a:spcPct val="90000"/>
+              </a:lnSpc>
+              <a:spcBef>
+                <a:spcPts val="1000"/>
+              </a:spcBef>
+            </a:pPr>
+            <a:r>
+              <a:rPr lang="en-US" sz="900" dirty="0">
+                <a:solidFill>
+                  <a:srgbClr val="333333"/>
+                </a:solidFill>
+                <a:latin typeface="Helvetica Neue" panose="02000503000000020004" pitchFamily="2" charset="0"/>
+              </a:rPr>
+              <a:t>Developing &amp; analyzing tools to measure specific learning outcomes. Novel approaches to assessment.</a:t>
+            </a:r>
+          </a:p>
+          <a:p>
+            <a:pPr>
+              <a:lnSpc>
+                <a:spcPct val="90000"/>
+              </a:lnSpc>
+              <a:spcBef>
+                <a:spcPts val="1000"/>
+              </a:spcBef>
+            </a:pPr>
+            <a:r>
+              <a:rPr lang="en-US" sz="900" dirty="0">
+                <a:solidFill>
+                  <a:srgbClr val="333333"/>
+                </a:solidFill>
+                <a:latin typeface="Helvetica Neue" panose="02000503000000020004" pitchFamily="2" charset="0"/>
+              </a:rPr>
+              <a:t>”Tests" for research across academic institutions;</a:t>
+            </a:r>
+          </a:p>
+          <a:p>
+            <a:pPr>
+              <a:lnSpc>
+                <a:spcPct val="90000"/>
+              </a:lnSpc>
+              <a:spcBef>
+                <a:spcPts val="1000"/>
+              </a:spcBef>
+            </a:pPr>
+            <a:r>
+              <a:rPr lang="en-US" sz="900" dirty="0">
+                <a:solidFill>
+                  <a:srgbClr val="333333"/>
+                </a:solidFill>
+                <a:latin typeface="Helvetica Neue" panose="02000503000000020004" pitchFamily="2" charset="0"/>
+              </a:rPr>
+              <a:t>Formative assessment; e.g., feedback for self-regulated learning and/or adaptive instruction</a:t>
+            </a:r>
+          </a:p>
+          <a:p>
+            <a:pPr>
+              <a:lnSpc>
+                <a:spcPct val="90000"/>
+              </a:lnSpc>
+              <a:spcBef>
+                <a:spcPts val="1000"/>
+              </a:spcBef>
+            </a:pPr>
+            <a:r>
+              <a:rPr lang="en-US" sz="800" dirty="0">
+                <a:solidFill>
+                  <a:srgbClr val="333333"/>
+                </a:solidFill>
+                <a:latin typeface="Helvetica Neue" panose="02000503000000020004" pitchFamily="2" charset="0"/>
+              </a:rPr>
+              <a:t>&gt; Sayali Phadke, Beckman, Lock Morgan (2024). Measuring contextualized statistical literacy: Evidence from an isomorphic assessment.</a:t>
+            </a:r>
+            <a:endParaRPr lang="en-US" sz="900" dirty="0">
+              <a:solidFill>
+                <a:srgbClr val="333333"/>
+              </a:solidFill>
+              <a:latin typeface="Helvetica Neue" panose="02000503000000020004" pitchFamily="2" charset="0"/>
+            </a:endParaRPr>
+          </a:p>
+          <a:p>
+            <a:pPr marL="171450" indent="-171450">
+              <a:lnSpc>
+                <a:spcPct val="90000"/>
+              </a:lnSpc>
+              <a:spcBef>
+                <a:spcPts val="1000"/>
+              </a:spcBef>
+              <a:buFont typeface="Arial" panose="020B0604020202020204" pitchFamily="34" charset="0"/>
+              <a:buChar char="•"/>
+            </a:pPr>
+            <a:r>
+              <a:rPr lang="en-US" sz="1250" dirty="0">
+                <a:solidFill>
+                  <a:srgbClr val="333333"/>
+                </a:solidFill>
+                <a:latin typeface="Helvetica Neue" panose="02000503000000020004" pitchFamily="2" charset="0"/>
+              </a:rPr>
+              <a:t>Data Science Education</a:t>
+            </a:r>
+          </a:p>
+          <a:p>
+            <a:pPr marL="0" marR="0" lvl="0" indent="0" algn="l" defTabSz="914400" rtl="0" eaLnBrk="1" fontAlgn="auto" latinLnBrk="0" hangingPunct="1">
+              <a:lnSpc>
+                <a:spcPct val="90000"/>
+              </a:lnSpc>
+              <a:spcBef>
+                <a:spcPts val="1000"/>
+              </a:spcBef>
+              <a:spcAft>
+                <a:spcPts val="0"/>
+              </a:spcAft>
+              <a:buClrTx/>
+              <a:buSzTx/>
+              <a:buFontTx/>
+              <a:buNone/>
+              <a:tabLst/>
+              <a:defRPr/>
+            </a:pPr>
+            <a:r>
+              <a:rPr kumimoji="0" lang="en-US" sz="900" b="0" i="0" u="none" strike="noStrike" kern="1200" cap="none" spc="0" normalizeH="0" baseline="0" noProof="0" dirty="0">
+                <a:ln>
+                  <a:noFill/>
+                </a:ln>
+                <a:solidFill>
+                  <a:srgbClr val="333333"/>
+                </a:solidFill>
+                <a:effectLst/>
+                <a:uLnTx/>
+                <a:uFillTx/>
+                <a:latin typeface="Helvetica Neue" panose="02000503000000020004" pitchFamily="2" charset="0"/>
+                <a:ea typeface="+mn-ea"/>
+                <a:cs typeface="+mn-cs"/>
+              </a:rPr>
+              <a:t>Intersection of stat education &amp; computing education</a:t>
+            </a:r>
+          </a:p>
+          <a:p>
+            <a:pPr marL="0" marR="0" lvl="0" indent="0" algn="l" defTabSz="914400" rtl="0" eaLnBrk="1" fontAlgn="auto" latinLnBrk="0" hangingPunct="1">
+              <a:lnSpc>
+                <a:spcPct val="90000"/>
+              </a:lnSpc>
+              <a:spcBef>
+                <a:spcPts val="1000"/>
+              </a:spcBef>
+              <a:spcAft>
+                <a:spcPts val="0"/>
+              </a:spcAft>
+              <a:buClrTx/>
+              <a:buSzTx/>
+              <a:buFontTx/>
+              <a:buNone/>
+              <a:tabLst/>
+              <a:defRPr/>
+            </a:pPr>
+            <a:r>
+              <a:rPr kumimoji="0" lang="en-US" sz="900" b="0" i="0" u="none" strike="noStrike" kern="1200" cap="none" spc="0" normalizeH="0" baseline="0" noProof="0" dirty="0">
+                <a:ln>
+                  <a:noFill/>
+                </a:ln>
+                <a:solidFill>
+                  <a:srgbClr val="333333"/>
+                </a:solidFill>
+                <a:effectLst/>
+                <a:uLnTx/>
+                <a:uFillTx/>
+                <a:latin typeface="Helvetica Neue" panose="02000503000000020004" pitchFamily="2" charset="0"/>
+                <a:ea typeface="+mn-ea"/>
+                <a:cs typeface="+mn-cs"/>
+              </a:rPr>
+              <a:t>Mixed</a:t>
+            </a:r>
+            <a:r>
+              <a:rPr lang="en-US" sz="900" dirty="0">
+                <a:solidFill>
+                  <a:srgbClr val="333333"/>
+                </a:solidFill>
+                <a:latin typeface="Helvetica Neue" panose="02000503000000020004" pitchFamily="2" charset="0"/>
+              </a:rPr>
+              <a:t>-methods analysis of Intro DS Course content</a:t>
+            </a:r>
+            <a:endParaRPr kumimoji="0" lang="en-US" sz="900" b="0" i="0" u="none" strike="noStrike" kern="1200" cap="none" spc="0" normalizeH="0" baseline="0" noProof="0" dirty="0">
+              <a:ln>
+                <a:noFill/>
+              </a:ln>
+              <a:solidFill>
+                <a:srgbClr val="333333"/>
+              </a:solidFill>
+              <a:effectLst/>
+              <a:uLnTx/>
+              <a:uFillTx/>
+              <a:latin typeface="Helvetica Neue" panose="02000503000000020004" pitchFamily="2" charset="0"/>
+              <a:ea typeface="+mn-ea"/>
+              <a:cs typeface="+mn-cs"/>
+            </a:endParaRPr>
+          </a:p>
+          <a:p>
+            <a:pPr marL="0" marR="0" lvl="0" indent="0" algn="l" defTabSz="914400" rtl="0" eaLnBrk="1" fontAlgn="auto" latinLnBrk="0" hangingPunct="1">
+              <a:lnSpc>
+                <a:spcPct val="90000"/>
+              </a:lnSpc>
+              <a:spcBef>
+                <a:spcPts val="1000"/>
+              </a:spcBef>
+              <a:spcAft>
+                <a:spcPts val="0"/>
+              </a:spcAft>
+              <a:buClrTx/>
+              <a:buSzTx/>
+              <a:buFontTx/>
+              <a:buNone/>
+              <a:tabLst/>
+              <a:defRPr/>
+            </a:pPr>
+            <a:r>
+              <a:rPr kumimoji="0" lang="en-US" sz="900" b="0" i="0" u="none" strike="noStrike" kern="1200" cap="none" spc="0" normalizeH="0" baseline="0" noProof="0" dirty="0">
+                <a:ln>
+                  <a:noFill/>
+                </a:ln>
+                <a:solidFill>
+                  <a:srgbClr val="333333"/>
+                </a:solidFill>
+                <a:effectLst/>
+                <a:uLnTx/>
+                <a:uFillTx/>
+                <a:latin typeface="Helvetica Neue" panose="02000503000000020004" pitchFamily="2" charset="0"/>
+                <a:ea typeface="+mn-ea"/>
+                <a:cs typeface="+mn-cs"/>
+              </a:rPr>
+              <a:t>Studying DS/CS topics introduced as learning objectives in statistics curricula</a:t>
+            </a:r>
+          </a:p>
+          <a:p>
+            <a:pPr marL="0" marR="0" lvl="0" indent="0" algn="l" defTabSz="914400" rtl="0" eaLnBrk="1" fontAlgn="auto" latinLnBrk="0" hangingPunct="1">
+              <a:lnSpc>
+                <a:spcPct val="90000"/>
+              </a:lnSpc>
+              <a:spcBef>
+                <a:spcPts val="1000"/>
+              </a:spcBef>
+              <a:spcAft>
+                <a:spcPts val="0"/>
+              </a:spcAft>
+              <a:buClrTx/>
+              <a:buSzTx/>
+              <a:buFontTx/>
+              <a:buNone/>
+              <a:tabLst/>
+              <a:defRPr/>
+            </a:pPr>
+            <a:r>
+              <a:rPr kumimoji="0" lang="en-US" sz="900" b="0" i="0" u="none" strike="noStrike" kern="1200" cap="none" spc="0" normalizeH="0" baseline="0" noProof="0" dirty="0">
+                <a:ln>
+                  <a:noFill/>
+                </a:ln>
+                <a:solidFill>
+                  <a:srgbClr val="333333"/>
+                </a:solidFill>
+                <a:effectLst/>
+                <a:uLnTx/>
+                <a:uFillTx/>
+                <a:latin typeface="Helvetica Neue" panose="02000503000000020004" pitchFamily="2" charset="0"/>
+                <a:ea typeface="+mn-ea"/>
+                <a:cs typeface="+mn-cs"/>
+              </a:rPr>
+              <a:t>Data literacy, data acumen, EDA for Data Science</a:t>
+            </a:r>
+          </a:p>
+          <a:p>
+            <a:pPr marL="0" marR="0" lvl="0" indent="0" algn="l" defTabSz="914400" rtl="0" eaLnBrk="1" fontAlgn="auto" latinLnBrk="0" hangingPunct="1">
+              <a:lnSpc>
+                <a:spcPct val="90000"/>
+              </a:lnSpc>
+              <a:spcBef>
+                <a:spcPts val="1000"/>
+              </a:spcBef>
+              <a:spcAft>
+                <a:spcPts val="0"/>
+              </a:spcAft>
+              <a:buClrTx/>
+              <a:buSzTx/>
+              <a:buFontTx/>
+              <a:buNone/>
+              <a:tabLst/>
+              <a:defRPr/>
+            </a:pPr>
+            <a:r>
+              <a:rPr kumimoji="0" lang="en-US" sz="800" b="0" i="0" u="none" strike="noStrike" kern="1200" cap="none" spc="0" normalizeH="0" baseline="0" noProof="0" dirty="0">
+                <a:ln>
+                  <a:noFill/>
+                </a:ln>
+                <a:solidFill>
+                  <a:srgbClr val="333333"/>
+                </a:solidFill>
+                <a:effectLst/>
+                <a:uLnTx/>
+                <a:uFillTx/>
+                <a:latin typeface="Helvetica Neue" panose="02000503000000020004" pitchFamily="2" charset="0"/>
+                <a:ea typeface="+mn-ea"/>
+                <a:cs typeface="+mn-cs"/>
+              </a:rPr>
+              <a:t>&gt; Alyssa Hu, Hatfield, Beckman (2025). Exploring individuals’ computational </a:t>
+            </a:r>
+            <a:r>
+              <a:rPr lang="en-US" sz="800" dirty="0">
+                <a:solidFill>
+                  <a:srgbClr val="333333"/>
+                </a:solidFill>
+                <a:latin typeface="Helvetica Neue" panose="02000503000000020004" pitchFamily="2" charset="0"/>
+              </a:rPr>
+              <a:t>t</a:t>
+            </a:r>
+            <a:r>
+              <a:rPr kumimoji="0" lang="en-US" sz="800" b="0" i="0" u="none" strike="noStrike" kern="1200" cap="none" spc="0" normalizeH="0" baseline="0" noProof="0" dirty="0" err="1">
+                <a:ln>
+                  <a:noFill/>
+                </a:ln>
+                <a:solidFill>
+                  <a:srgbClr val="333333"/>
+                </a:solidFill>
+                <a:effectLst/>
+                <a:uLnTx/>
+                <a:uFillTx/>
+                <a:latin typeface="Helvetica Neue" panose="02000503000000020004" pitchFamily="2" charset="0"/>
+                <a:ea typeface="+mn-ea"/>
+                <a:cs typeface="+mn-cs"/>
+              </a:rPr>
+              <a:t>hinking</a:t>
+            </a:r>
+            <a:r>
+              <a:rPr kumimoji="0" lang="en-US" sz="800" b="0" i="0" u="none" strike="noStrike" kern="1200" cap="none" spc="0" normalizeH="0" baseline="0" noProof="0" dirty="0">
+                <a:ln>
+                  <a:noFill/>
+                </a:ln>
+                <a:solidFill>
+                  <a:srgbClr val="333333"/>
+                </a:solidFill>
+                <a:effectLst/>
+                <a:uLnTx/>
+                <a:uFillTx/>
+                <a:latin typeface="Helvetica Neue" panose="02000503000000020004" pitchFamily="2" charset="0"/>
+                <a:ea typeface="+mn-ea"/>
+                <a:cs typeface="+mn-cs"/>
+              </a:rPr>
+              <a:t> with data. ZDM Mathematics Education, 57.</a:t>
+            </a:r>
+          </a:p>
+          <a:p>
+            <a:pPr marL="0" marR="0" lvl="0" indent="0" algn="l" defTabSz="914400" rtl="0" eaLnBrk="1" fontAlgn="auto" latinLnBrk="0" hangingPunct="1">
+              <a:lnSpc>
+                <a:spcPct val="90000"/>
+              </a:lnSpc>
+              <a:spcBef>
+                <a:spcPts val="1000"/>
+              </a:spcBef>
+              <a:spcAft>
+                <a:spcPts val="0"/>
+              </a:spcAft>
+              <a:buClrTx/>
+              <a:buSzTx/>
+              <a:buFontTx/>
+              <a:buNone/>
+              <a:tabLst/>
+              <a:defRPr/>
+            </a:pPr>
+            <a:r>
+              <a:rPr kumimoji="0" lang="en-US" sz="800" b="0" i="0" u="none" strike="noStrike" kern="1200" cap="none" spc="0" normalizeH="0" baseline="0" noProof="0" dirty="0">
+                <a:ln>
+                  <a:noFill/>
+                </a:ln>
+                <a:solidFill>
+                  <a:srgbClr val="333333"/>
+                </a:solidFill>
+                <a:effectLst/>
+                <a:uLnTx/>
+                <a:uFillTx/>
+                <a:latin typeface="Helvetica Neue" panose="02000503000000020004" pitchFamily="2" charset="0"/>
+                <a:ea typeface="+mn-ea"/>
+                <a:cs typeface="+mn-cs"/>
+              </a:rPr>
+              <a:t>&gt; Beckman et al (2021). Implementing Version Control With Git and GitHub as a Learning Objective in Statistics and Data Science Courses. JSDSE, 29(1).</a:t>
+            </a:r>
+            <a:endParaRPr lang="en-US" sz="1250" dirty="0">
+              <a:solidFill>
+                <a:srgbClr val="333333"/>
+              </a:solidFill>
+              <a:latin typeface="Helvetica Neue" panose="02000503000000020004" pitchFamily="2" charset="0"/>
+            </a:endParaRPr>
+          </a:p>
+        </p:txBody>
+      </p:sp>
       <p:pic>
         <p:nvPicPr>
-          <p:cNvPr id="12" name="Picture 11" descr="A logo of a globe with a gold cogwheel&#10;&#10;Description automatically generated">
+          <p:cNvPr id="8" name="Picture 7" descr="A qr code with a white background&#10;&#10;AI-generated content may be incorrect.">
             <a:extLst>
               <a:ext uri="{FF2B5EF4-FFF2-40B4-BE49-F238E27FC236}">
-                <a16:creationId xmlns:a16="http://schemas.microsoft.com/office/drawing/2014/main" id="{68747CA0-270C-1B00-05B3-6C1055FF0774}"/>
+                <a16:creationId xmlns:a16="http://schemas.microsoft.com/office/drawing/2014/main" id="{6C294BF9-9AF7-7B2E-BE08-82EDDEC23765}"/>
               </a:ext>
             </a:extLst>
           </p:cNvPr>
@@ -3439,412 +3944,20 @@
         </p:blipFill>
         <p:spPr>
           <a:xfrm>
-            <a:off x="111302" y="6430618"/>
-            <a:ext cx="427382" cy="427382"/>
+            <a:off x="5587368" y="2149849"/>
+            <a:ext cx="2686050" cy="2686050"/>
           </a:xfrm>
           <a:prstGeom prst="rect">
             <a:avLst/>
           </a:prstGeom>
         </p:spPr>
       </p:pic>
-      <p:sp>
-        <p:nvSpPr>
-          <p:cNvPr id="5" name="TextBox 4">
+      <p:pic>
+        <p:nvPicPr>
+          <p:cNvPr id="13" name="Picture 12" descr="A diagram of a framework&#10;&#10;AI-generated content may be incorrect.">
             <a:extLst>
               <a:ext uri="{FF2B5EF4-FFF2-40B4-BE49-F238E27FC236}">
-                <a16:creationId xmlns:a16="http://schemas.microsoft.com/office/drawing/2014/main" id="{BEC779EE-343C-5AD2-5686-9E9B963EF0BF}"/>
-              </a:ext>
-            </a:extLst>
-          </p:cNvPr>
-          <p:cNvSpPr txBox="1"/>
-          <p:nvPr/>
-        </p:nvSpPr>
-        <p:spPr>
-          <a:xfrm>
-            <a:off x="9140777" y="127748"/>
-            <a:ext cx="2939922" cy="4260654"/>
-          </a:xfrm>
-          <a:prstGeom prst="rect">
-            <a:avLst/>
-          </a:prstGeom>
-          <a:noFill/>
-        </p:spPr>
-        <p:txBody>
-          <a:bodyPr wrap="square" rtlCol="0">
-            <a:spAutoFit/>
-          </a:bodyPr>
-          <a:lstStyle/>
-          <a:p>
-            <a:r>
-              <a:rPr lang="en-US" sz="1900" b="1" dirty="0">
-                <a:solidFill>
-                  <a:schemeClr val="accent2"/>
-                </a:solidFill>
-              </a:rPr>
-              <a:t>Other Projects/Interests</a:t>
-            </a:r>
-          </a:p>
-          <a:p>
-            <a:pPr marL="171450" indent="-171450">
-              <a:lnSpc>
-                <a:spcPct val="90000"/>
-              </a:lnSpc>
-              <a:spcBef>
-                <a:spcPts val="1000"/>
-              </a:spcBef>
-              <a:buFont typeface="Arial" panose="020B0604020202020204" pitchFamily="34" charset="0"/>
-              <a:buChar char="•"/>
-            </a:pPr>
-            <a:r>
-              <a:rPr lang="en-US" sz="1250" dirty="0">
-                <a:solidFill>
-                  <a:srgbClr val="333333"/>
-                </a:solidFill>
-                <a:latin typeface="Helvetica Neue" panose="02000503000000020004" pitchFamily="2" charset="0"/>
-              </a:rPr>
-              <a:t>Educational Assessment</a:t>
-            </a:r>
-          </a:p>
-          <a:p>
-            <a:pPr>
-              <a:lnSpc>
-                <a:spcPct val="90000"/>
-              </a:lnSpc>
-              <a:spcBef>
-                <a:spcPts val="1000"/>
-              </a:spcBef>
-            </a:pPr>
-            <a:r>
-              <a:rPr lang="en-US" sz="900" dirty="0">
-                <a:solidFill>
-                  <a:srgbClr val="333333"/>
-                </a:solidFill>
-                <a:latin typeface="Helvetica Neue" panose="02000503000000020004" pitchFamily="2" charset="0"/>
-              </a:rPr>
-              <a:t>Developing &amp; analyzing tools to measure specific learning outcomes. Novel approaches to assessment.</a:t>
-            </a:r>
-          </a:p>
-          <a:p>
-            <a:pPr>
-              <a:lnSpc>
-                <a:spcPct val="90000"/>
-              </a:lnSpc>
-              <a:spcBef>
-                <a:spcPts val="1000"/>
-              </a:spcBef>
-            </a:pPr>
-            <a:r>
-              <a:rPr lang="en-US" sz="900" dirty="0">
-                <a:solidFill>
-                  <a:srgbClr val="333333"/>
-                </a:solidFill>
-                <a:latin typeface="Helvetica Neue" panose="02000503000000020004" pitchFamily="2" charset="0"/>
-              </a:rPr>
-              <a:t>”Tests" for research across academic institutions;</a:t>
-            </a:r>
-          </a:p>
-          <a:p>
-            <a:pPr>
-              <a:lnSpc>
-                <a:spcPct val="90000"/>
-              </a:lnSpc>
-              <a:spcBef>
-                <a:spcPts val="1000"/>
-              </a:spcBef>
-            </a:pPr>
-            <a:r>
-              <a:rPr lang="en-US" sz="900" dirty="0">
-                <a:solidFill>
-                  <a:srgbClr val="333333"/>
-                </a:solidFill>
-                <a:latin typeface="Helvetica Neue" panose="02000503000000020004" pitchFamily="2" charset="0"/>
-              </a:rPr>
-              <a:t>Formative assessment; e.g., feedback for self-regulated learning and/or adaptive instruction</a:t>
-            </a:r>
-          </a:p>
-          <a:p>
-            <a:pPr>
-              <a:lnSpc>
-                <a:spcPct val="90000"/>
-              </a:lnSpc>
-              <a:spcBef>
-                <a:spcPts val="1000"/>
-              </a:spcBef>
-            </a:pPr>
-            <a:r>
-              <a:rPr lang="en-US" sz="800" dirty="0">
-                <a:solidFill>
-                  <a:srgbClr val="333333"/>
-                </a:solidFill>
-                <a:latin typeface="Helvetica Neue" panose="02000503000000020004" pitchFamily="2" charset="0"/>
-              </a:rPr>
-              <a:t>&gt; Sayali Phadke, Beckman, Lock Morgan (2024). Measuring contextualized statistical literacy: Evidence from an isomorphic assessment.</a:t>
-            </a:r>
-            <a:endParaRPr lang="en-US" sz="900" dirty="0">
-              <a:solidFill>
-                <a:srgbClr val="333333"/>
-              </a:solidFill>
-              <a:latin typeface="Helvetica Neue" panose="02000503000000020004" pitchFamily="2" charset="0"/>
-            </a:endParaRPr>
-          </a:p>
-          <a:p>
-            <a:pPr marL="171450" indent="-171450">
-              <a:lnSpc>
-                <a:spcPct val="90000"/>
-              </a:lnSpc>
-              <a:spcBef>
-                <a:spcPts val="1000"/>
-              </a:spcBef>
-              <a:buFont typeface="Arial" panose="020B0604020202020204" pitchFamily="34" charset="0"/>
-              <a:buChar char="•"/>
-            </a:pPr>
-            <a:r>
-              <a:rPr lang="en-US" sz="1250" dirty="0">
-                <a:solidFill>
-                  <a:srgbClr val="333333"/>
-                </a:solidFill>
-                <a:latin typeface="Helvetica Neue" panose="02000503000000020004" pitchFamily="2" charset="0"/>
-              </a:rPr>
-              <a:t>Data Science Education</a:t>
-            </a:r>
-          </a:p>
-          <a:p>
-            <a:pPr marL="0" marR="0" lvl="0" indent="0" algn="l" defTabSz="914400" rtl="0" eaLnBrk="1" fontAlgn="auto" latinLnBrk="0" hangingPunct="1">
-              <a:lnSpc>
-                <a:spcPct val="90000"/>
-              </a:lnSpc>
-              <a:spcBef>
-                <a:spcPts val="1000"/>
-              </a:spcBef>
-              <a:spcAft>
-                <a:spcPts val="0"/>
-              </a:spcAft>
-              <a:buClrTx/>
-              <a:buSzTx/>
-              <a:buFontTx/>
-              <a:buNone/>
-              <a:tabLst/>
-              <a:defRPr/>
-            </a:pPr>
-            <a:r>
-              <a:rPr kumimoji="0" lang="en-US" sz="900" b="0" i="0" u="none" strike="noStrike" kern="1200" cap="none" spc="0" normalizeH="0" baseline="0" noProof="0" dirty="0">
-                <a:ln>
-                  <a:noFill/>
-                </a:ln>
-                <a:solidFill>
-                  <a:srgbClr val="333333"/>
-                </a:solidFill>
-                <a:effectLst/>
-                <a:uLnTx/>
-                <a:uFillTx/>
-                <a:latin typeface="Helvetica Neue" panose="02000503000000020004" pitchFamily="2" charset="0"/>
-                <a:ea typeface="+mn-ea"/>
-                <a:cs typeface="+mn-cs"/>
-              </a:rPr>
-              <a:t>Intersection of stat education &amp; computing education</a:t>
-            </a:r>
-          </a:p>
-          <a:p>
-            <a:pPr marL="0" marR="0" lvl="0" indent="0" algn="l" defTabSz="914400" rtl="0" eaLnBrk="1" fontAlgn="auto" latinLnBrk="0" hangingPunct="1">
-              <a:lnSpc>
-                <a:spcPct val="90000"/>
-              </a:lnSpc>
-              <a:spcBef>
-                <a:spcPts val="1000"/>
-              </a:spcBef>
-              <a:spcAft>
-                <a:spcPts val="0"/>
-              </a:spcAft>
-              <a:buClrTx/>
-              <a:buSzTx/>
-              <a:buFontTx/>
-              <a:buNone/>
-              <a:tabLst/>
-              <a:defRPr/>
-            </a:pPr>
-            <a:r>
-              <a:rPr kumimoji="0" lang="en-US" sz="900" b="0" i="0" u="none" strike="noStrike" kern="1200" cap="none" spc="0" normalizeH="0" baseline="0" noProof="0" dirty="0">
-                <a:ln>
-                  <a:noFill/>
-                </a:ln>
-                <a:solidFill>
-                  <a:srgbClr val="333333"/>
-                </a:solidFill>
-                <a:effectLst/>
-                <a:uLnTx/>
-                <a:uFillTx/>
-                <a:latin typeface="Helvetica Neue" panose="02000503000000020004" pitchFamily="2" charset="0"/>
-                <a:ea typeface="+mn-ea"/>
-                <a:cs typeface="+mn-cs"/>
-              </a:rPr>
-              <a:t>Studying DS/CS topics introduced as learning objectives in statistics curricula</a:t>
-            </a:r>
-          </a:p>
-          <a:p>
-            <a:pPr marL="0" marR="0" lvl="0" indent="0" algn="l" defTabSz="914400" rtl="0" eaLnBrk="1" fontAlgn="auto" latinLnBrk="0" hangingPunct="1">
-              <a:lnSpc>
-                <a:spcPct val="90000"/>
-              </a:lnSpc>
-              <a:spcBef>
-                <a:spcPts val="1000"/>
-              </a:spcBef>
-              <a:spcAft>
-                <a:spcPts val="0"/>
-              </a:spcAft>
-              <a:buClrTx/>
-              <a:buSzTx/>
-              <a:buFontTx/>
-              <a:buNone/>
-              <a:tabLst/>
-              <a:defRPr/>
-            </a:pPr>
-            <a:r>
-              <a:rPr kumimoji="0" lang="en-US" sz="900" b="0" i="0" u="none" strike="noStrike" kern="1200" cap="none" spc="0" normalizeH="0" baseline="0" noProof="0" dirty="0">
-                <a:ln>
-                  <a:noFill/>
-                </a:ln>
-                <a:solidFill>
-                  <a:srgbClr val="333333"/>
-                </a:solidFill>
-                <a:effectLst/>
-                <a:uLnTx/>
-                <a:uFillTx/>
-                <a:latin typeface="Helvetica Neue" panose="02000503000000020004" pitchFamily="2" charset="0"/>
-                <a:ea typeface="+mn-ea"/>
-                <a:cs typeface="+mn-cs"/>
-              </a:rPr>
-              <a:t>Data literacy, data acumen, EDA for Data Science</a:t>
-            </a:r>
-          </a:p>
-          <a:p>
-            <a:pPr marL="0" marR="0" lvl="0" indent="0" algn="l" defTabSz="914400" rtl="0" eaLnBrk="1" fontAlgn="auto" latinLnBrk="0" hangingPunct="1">
-              <a:lnSpc>
-                <a:spcPct val="90000"/>
-              </a:lnSpc>
-              <a:spcBef>
-                <a:spcPts val="1000"/>
-              </a:spcBef>
-              <a:spcAft>
-                <a:spcPts val="0"/>
-              </a:spcAft>
-              <a:buClrTx/>
-              <a:buSzTx/>
-              <a:buFontTx/>
-              <a:buNone/>
-              <a:tabLst/>
-              <a:defRPr/>
-            </a:pPr>
-            <a:r>
-              <a:rPr kumimoji="0" lang="en-US" sz="800" b="0" i="0" u="none" strike="noStrike" kern="1200" cap="none" spc="0" normalizeH="0" baseline="0" noProof="0" dirty="0">
-                <a:ln>
-                  <a:noFill/>
-                </a:ln>
-                <a:solidFill>
-                  <a:srgbClr val="333333"/>
-                </a:solidFill>
-                <a:effectLst/>
-                <a:uLnTx/>
-                <a:uFillTx/>
-                <a:latin typeface="Helvetica Neue" panose="02000503000000020004" pitchFamily="2" charset="0"/>
-                <a:ea typeface="+mn-ea"/>
-                <a:cs typeface="+mn-cs"/>
-              </a:rPr>
-              <a:t>&gt; Alyssa Hu, Hatfield, Beckman (2025). Exploring individuals’ computational </a:t>
-            </a:r>
-            <a:r>
-              <a:rPr lang="en-US" sz="800" dirty="0">
-                <a:solidFill>
-                  <a:srgbClr val="333333"/>
-                </a:solidFill>
-                <a:latin typeface="Helvetica Neue" panose="02000503000000020004" pitchFamily="2" charset="0"/>
-              </a:rPr>
-              <a:t>t</a:t>
-            </a:r>
-            <a:r>
-              <a:rPr kumimoji="0" lang="en-US" sz="800" b="0" i="0" u="none" strike="noStrike" kern="1200" cap="none" spc="0" normalizeH="0" baseline="0" noProof="0" dirty="0" err="1">
-                <a:ln>
-                  <a:noFill/>
-                </a:ln>
-                <a:solidFill>
-                  <a:srgbClr val="333333"/>
-                </a:solidFill>
-                <a:effectLst/>
-                <a:uLnTx/>
-                <a:uFillTx/>
-                <a:latin typeface="Helvetica Neue" panose="02000503000000020004" pitchFamily="2" charset="0"/>
-                <a:ea typeface="+mn-ea"/>
-                <a:cs typeface="+mn-cs"/>
-              </a:rPr>
-              <a:t>hinking</a:t>
-            </a:r>
-            <a:r>
-              <a:rPr kumimoji="0" lang="en-US" sz="800" b="0" i="0" u="none" strike="noStrike" kern="1200" cap="none" spc="0" normalizeH="0" baseline="0" noProof="0" dirty="0">
-                <a:ln>
-                  <a:noFill/>
-                </a:ln>
-                <a:solidFill>
-                  <a:srgbClr val="333333"/>
-                </a:solidFill>
-                <a:effectLst/>
-                <a:uLnTx/>
-                <a:uFillTx/>
-                <a:latin typeface="Helvetica Neue" panose="02000503000000020004" pitchFamily="2" charset="0"/>
-                <a:ea typeface="+mn-ea"/>
-                <a:cs typeface="+mn-cs"/>
-              </a:rPr>
-              <a:t> with data. ZDM Mathematics Education, 57.</a:t>
-            </a:r>
-          </a:p>
-          <a:p>
-            <a:pPr marL="0" marR="0" lvl="0" indent="0" algn="l" defTabSz="914400" rtl="0" eaLnBrk="1" fontAlgn="auto" latinLnBrk="0" hangingPunct="1">
-              <a:lnSpc>
-                <a:spcPct val="90000"/>
-              </a:lnSpc>
-              <a:spcBef>
-                <a:spcPts val="1000"/>
-              </a:spcBef>
-              <a:spcAft>
-                <a:spcPts val="0"/>
-              </a:spcAft>
-              <a:buClrTx/>
-              <a:buSzTx/>
-              <a:buFontTx/>
-              <a:buNone/>
-              <a:tabLst/>
-              <a:defRPr/>
-            </a:pPr>
-            <a:r>
-              <a:rPr kumimoji="0" lang="en-US" sz="800" b="0" i="0" u="none" strike="noStrike" kern="1200" cap="none" spc="0" normalizeH="0" baseline="0" noProof="0" dirty="0">
-                <a:ln>
-                  <a:noFill/>
-                </a:ln>
-                <a:solidFill>
-                  <a:srgbClr val="333333"/>
-                </a:solidFill>
-                <a:effectLst/>
-                <a:uLnTx/>
-                <a:uFillTx/>
-                <a:latin typeface="Helvetica Neue" panose="02000503000000020004" pitchFamily="2" charset="0"/>
-                <a:ea typeface="+mn-ea"/>
-                <a:cs typeface="+mn-cs"/>
-              </a:rPr>
-              <a:t>&gt; Beckman et al (2021). Implementing Version Control With Git and GitHub as a Learning Objective in Statistics and Data Science Courses. JSDSE, 29(1).</a:t>
-            </a:r>
-            <a:endParaRPr lang="en-US" sz="1250" dirty="0">
-              <a:solidFill>
-                <a:srgbClr val="333333"/>
-              </a:solidFill>
-              <a:latin typeface="Helvetica Neue" panose="02000503000000020004" pitchFamily="2" charset="0"/>
-            </a:endParaRPr>
-          </a:p>
-        </p:txBody>
-      </p:sp>
-      <p:pic>
-        <p:nvPicPr>
-          <p:cNvPr id="8" name="Picture 7" descr="A qr code with a white background&#10;&#10;AI-generated content may be incorrect.">
-            <a:extLst>
-              <a:ext uri="{FF2B5EF4-FFF2-40B4-BE49-F238E27FC236}">
-                <a16:creationId xmlns:a16="http://schemas.microsoft.com/office/drawing/2014/main" id="{6C294BF9-9AF7-7B2E-BE08-82EDDEC23765}"/>
+                <a16:creationId xmlns:a16="http://schemas.microsoft.com/office/drawing/2014/main" id="{83A146D2-EABF-E290-F327-E28037C5C12C}"/>
               </a:ext>
             </a:extLst>
           </p:cNvPr>
@@ -3867,8 +3980,8 @@
         </p:blipFill>
         <p:spPr>
           <a:xfrm>
-            <a:off x="5587368" y="2149849"/>
-            <a:ext cx="2686050" cy="2686050"/>
+            <a:off x="58548" y="1714500"/>
+            <a:ext cx="4804920" cy="2770872"/>
           </a:xfrm>
           <a:prstGeom prst="rect">
             <a:avLst/>

</xml_diff>

<commit_message>
add acknowledgements and minor edits to landing page
</commit_message>
<xml_diff>
--- a/docs/2026-Beckman-Research.pptx
+++ b/docs/2026-Beckman-Research.pptx
@@ -208,7 +208,7 @@
           <a:p>
             <a:fld id="{ECD1C33D-175C-4448-AC53-4345F676D392}" type="datetimeFigureOut">
               <a:rPr lang="en-US" smtClean="0"/>
-              <a:t>2/4/26</a:t>
+              <a:t>2/5/26</a:t>
             </a:fld>
             <a:endParaRPr lang="en-US" dirty="0"/>
           </a:p>
@@ -1991,7 +1991,7 @@
           <a:p>
             <a:fld id="{6FEC4368-C769-8143-B102-F97927FA2E0C}" type="datetimeFigureOut">
               <a:rPr lang="en-US" smtClean="0"/>
-              <a:t>2/4/26</a:t>
+              <a:t>2/5/26</a:t>
             </a:fld>
             <a:endParaRPr lang="en-US" dirty="0"/>
           </a:p>
@@ -2369,8 +2369,8 @@
         </p:nvSpPr>
         <p:spPr>
           <a:xfrm>
-            <a:off x="111301" y="127748"/>
-            <a:ext cx="4809074" cy="6730252"/>
+            <a:off x="0" y="127748"/>
+            <a:ext cx="5143500" cy="6730252"/>
           </a:xfrm>
         </p:spPr>
         <p:txBody>
@@ -2383,7 +2383,7 @@
               <a:buNone/>
             </a:pPr>
             <a:r>
-              <a:rPr lang="en-US" sz="2000" b="1" i="0" dirty="0">
+              <a:rPr lang="en-US" sz="1900" b="1" i="0" dirty="0">
                 <a:solidFill>
                   <a:schemeClr val="accent2"/>
                 </a:solidFill>
@@ -2393,7 +2393,7 @@
               <a:t>AI-support for teaching and learning at </a:t>
             </a:r>
             <a:r>
-              <a:rPr lang="en-US" sz="2000" b="1" i="0" u="sng" dirty="0">
+              <a:rPr lang="en-US" sz="1900" b="1" i="0" u="sng" dirty="0">
                 <a:solidFill>
                   <a:schemeClr val="accent2"/>
                 </a:solidFill>
@@ -2405,7 +2405,7 @@
           </a:p>
           <a:p>
             <a:r>
-              <a:rPr lang="en-US" sz="1200" dirty="0">
+              <a:rPr lang="en-US" sz="1100" dirty="0">
                 <a:solidFill>
                   <a:srgbClr val="333333"/>
                 </a:solidFill>
@@ -2416,33 +2416,25 @@
           </a:p>
           <a:p>
             <a:r>
-              <a:rPr lang="en-US" sz="1200" dirty="0">
-                <a:solidFill>
-                  <a:srgbClr val="333333"/>
-                </a:solidFill>
-                <a:latin typeface="Helvetica Neue" panose="02000503000000020004" pitchFamily="2" charset="0"/>
-              </a:rPr>
-              <a:t>Logistical obstacles impair pedagogical best practices</a:t>
-            </a:r>
-          </a:p>
-          <a:p>
-            <a:r>
-              <a:rPr lang="en-US" sz="1200" dirty="0">
-                <a:solidFill>
-                  <a:srgbClr val="333333"/>
-                </a:solidFill>
-                <a:latin typeface="Helvetica Neue" panose="02000503000000020004" pitchFamily="2" charset="0"/>
-              </a:rPr>
-              <a:t>Investigating NLP tools with human-in-the-loop architecture to facilitate scalability—improve student benefit while mitigating instructor burden</a:t>
-            </a:r>
-          </a:p>
-          <a:p>
-            <a:endParaRPr lang="en-US" sz="1200" dirty="0">
-              <a:solidFill>
-                <a:srgbClr val="333333"/>
-              </a:solidFill>
-              <a:latin typeface="Helvetica Neue" panose="02000503000000020004" pitchFamily="2" charset="0"/>
-            </a:endParaRPr>
+              <a:rPr lang="en-US" sz="1100" dirty="0">
+                <a:solidFill>
+                  <a:srgbClr val="333333"/>
+                </a:solidFill>
+                <a:latin typeface="Helvetica Neue" panose="02000503000000020004" pitchFamily="2" charset="0"/>
+              </a:rPr>
+              <a:t>Develop LLM and AI-based tools intended to amplify instructor efforts to provide timely, personalized feedback</a:t>
+            </a:r>
+          </a:p>
+          <a:p>
+            <a:r>
+              <a:rPr lang="en-US" sz="1100" dirty="0">
+                <a:solidFill>
+                  <a:srgbClr val="333333"/>
+                </a:solidFill>
+                <a:latin typeface="Helvetica Neue" panose="02000503000000020004" pitchFamily="2" charset="0"/>
+              </a:rPr>
+              <a:t>Build trust and confidence that human-AI partnerships make a responsible contribution</a:t>
+            </a:r>
           </a:p>
           <a:p>
             <a:endParaRPr lang="en-US" sz="1200" dirty="0">
@@ -2659,22 +2651,13 @@
               <a:buNone/>
             </a:pPr>
             <a:r>
-              <a:rPr lang="en-US" sz="900">
-                <a:solidFill>
-                  <a:srgbClr val="333333"/>
-                </a:solidFill>
-                <a:latin typeface="Helvetica Neue" panose="02000503000000020004" pitchFamily="2" charset="0"/>
-              </a:rPr>
-              <a:t>Li, </a:t>
-            </a:r>
-            <a:r>
               <a:rPr lang="en-US" sz="900" dirty="0">
                 <a:solidFill>
                   <a:srgbClr val="333333"/>
                 </a:solidFill>
                 <a:latin typeface="Helvetica Neue" panose="02000503000000020004" pitchFamily="2" charset="0"/>
               </a:rPr>
-              <a:t>Susan Lloyd, Beckman, &amp; </a:t>
+              <a:t>Li, Susan Lloyd, Beckman, &amp; </a:t>
             </a:r>
             <a:r>
               <a:rPr lang="en-US" sz="900" dirty="0" err="1">
@@ -2819,28 +2802,7 @@
               </a:spcBef>
               <a:buNone/>
             </a:pPr>
-            <a:endParaRPr lang="en-US" sz="900" b="0" i="0" dirty="0">
-              <a:solidFill>
-                <a:srgbClr val="333333"/>
-              </a:solidFill>
-              <a:effectLst/>
-              <a:latin typeface="Helvetica Neue" panose="02000503000000020004" pitchFamily="2" charset="0"/>
-            </a:endParaRPr>
-          </a:p>
-          <a:p>
-            <a:pPr marL="0" indent="0">
-              <a:buNone/>
-            </a:pPr>
-            <a:r>
-              <a:rPr lang="en-US" sz="1100" dirty="0">
-                <a:solidFill>
-                  <a:srgbClr val="333333"/>
-                </a:solidFill>
-                <a:latin typeface="Helvetica Neue" panose="02000503000000020004" pitchFamily="2" charset="0"/>
-              </a:rPr>
-              <a:t>           NSF Awards 2236150 &amp; 2423026; Penn State CSRAI Seed Grant #025243</a:t>
-            </a:r>
-            <a:endParaRPr lang="en-US" sz="1300" dirty="0">
+            <a:endParaRPr lang="en-US" sz="1100" dirty="0">
               <a:solidFill>
                 <a:srgbClr val="333333"/>
               </a:solidFill>
@@ -2851,7 +2813,44 @@
             <a:pPr marL="0" indent="0">
               <a:buNone/>
             </a:pPr>
-            <a:endParaRPr lang="en-US" sz="1100" dirty="0">
+            <a:r>
+              <a:rPr lang="en-US" sz="900" dirty="0">
+                <a:solidFill>
+                  <a:srgbClr val="333333"/>
+                </a:solidFill>
+                <a:latin typeface="Helvetica Neue" panose="02000503000000020004" pitchFamily="2" charset="0"/>
+              </a:rPr>
+              <a:t>           NSF Awards 2236150 &amp; 2423026 </a:t>
+            </a:r>
+          </a:p>
+          <a:p>
+            <a:pPr marL="0" indent="0">
+              <a:buNone/>
+            </a:pPr>
+            <a:r>
+              <a:rPr lang="en-US" sz="900" dirty="0">
+                <a:solidFill>
+                  <a:srgbClr val="333333"/>
+                </a:solidFill>
+                <a:latin typeface="Helvetica Neue" panose="02000503000000020004" pitchFamily="2" charset="0"/>
+              </a:rPr>
+              <a:t>Penn State CSRAI Seed Grant #025243 </a:t>
+            </a:r>
+          </a:p>
+          <a:p>
+            <a:pPr marL="0" indent="0">
+              <a:buNone/>
+            </a:pPr>
+            <a:r>
+              <a:rPr lang="en-US" sz="900" dirty="0">
+                <a:solidFill>
+                  <a:srgbClr val="333333"/>
+                </a:solidFill>
+                <a:latin typeface="Helvetica Neue" panose="02000503000000020004" pitchFamily="2" charset="0"/>
+              </a:rPr>
+              <a:t>Penn State Global Strategic Partnership with University of Auckland (NZ)</a:t>
+            </a:r>
+            <a:endParaRPr lang="en-US" sz="1200" dirty="0">
               <a:solidFill>
                 <a:srgbClr val="333333"/>
               </a:solidFill>
@@ -2935,8 +2934,8 @@
         </p:nvSpPr>
         <p:spPr>
           <a:xfrm>
-            <a:off x="4910763" y="272204"/>
-            <a:ext cx="4135423" cy="5303096"/>
+            <a:off x="5143500" y="272204"/>
+            <a:ext cx="3902686" cy="5303096"/>
           </a:xfrm>
           <a:prstGeom prst="rect">
             <a:avLst/>
@@ -3304,7 +3303,7 @@
                   <a:schemeClr val="accent2"/>
                 </a:solidFill>
               </a:rPr>
-              <a:t>Curious about SDSE?</a:t>
+              <a:t>Want to learn more?</a:t>
             </a:r>
           </a:p>
           <a:p>
@@ -3346,25 +3345,7 @@
                 </a:solidFill>
                 <a:latin typeface="Helvetica Neue" panose="02000503000000020004" pitchFamily="2" charset="0"/>
               </a:rPr>
-              <a:t>Conferences: JSM; </a:t>
-            </a:r>
-            <a:r>
-              <a:rPr lang="en-US" sz="1000" dirty="0" err="1">
-                <a:solidFill>
-                  <a:srgbClr val="333333"/>
-                </a:solidFill>
-                <a:latin typeface="Helvetica Neue" panose="02000503000000020004" pitchFamily="2" charset="0"/>
-              </a:rPr>
-              <a:t>eCOTS</a:t>
-            </a:r>
-            <a:r>
-              <a:rPr lang="en-US" sz="1000" dirty="0">
-                <a:solidFill>
-                  <a:srgbClr val="333333"/>
-                </a:solidFill>
-                <a:latin typeface="Helvetica Neue" panose="02000503000000020004" pitchFamily="2" charset="0"/>
-              </a:rPr>
-              <a:t> 2026</a:t>
+              <a:t>Drop by my office! (420 Thomas)</a:t>
             </a:r>
           </a:p>
           <a:p>
@@ -3382,7 +3363,25 @@
                 </a:solidFill>
                 <a:latin typeface="Helvetica Neue" panose="02000503000000020004" pitchFamily="2" charset="0"/>
               </a:rPr>
-              <a:t>IASE catalog of PhD dissertations</a:t>
+              <a:t>Ashtekar Lecture Feb 28</a:t>
+            </a:r>
+            <a:r>
+              <a:rPr lang="en-US" sz="1000" baseline="30000" dirty="0">
+                <a:solidFill>
+                  <a:srgbClr val="333333"/>
+                </a:solidFill>
+                <a:latin typeface="Helvetica Neue" panose="02000503000000020004" pitchFamily="2" charset="0"/>
+              </a:rPr>
+              <a:t>th</a:t>
+            </a:r>
+            <a:r>
+              <a:rPr lang="en-US" sz="1000" dirty="0">
+                <a:solidFill>
+                  <a:srgbClr val="333333"/>
+                </a:solidFill>
+                <a:latin typeface="Helvetica Neue" panose="02000503000000020004" pitchFamily="2" charset="0"/>
+              </a:rPr>
+              <a:t> @ 11am</a:t>
             </a:r>
           </a:p>
           <a:p>
@@ -3394,20 +3393,32 @@
               <a:buChar char="•"/>
             </a:pPr>
             <a:r>
+              <a:rPr lang="en-US" sz="1000" dirty="0">
+                <a:solidFill>
+                  <a:srgbClr val="333333"/>
+                </a:solidFill>
+                <a:latin typeface="Helvetica Neue" panose="02000503000000020004" pitchFamily="2" charset="0"/>
+              </a:rPr>
+              <a:t>Conferences: JSM; </a:t>
+            </a:r>
+            <a:r>
               <a:rPr lang="en-US" sz="1000" dirty="0" err="1">
                 <a:solidFill>
                   <a:srgbClr val="333333"/>
                 </a:solidFill>
                 <a:latin typeface="Helvetica Neue" panose="02000503000000020004" pitchFamily="2" charset="0"/>
               </a:rPr>
-              <a:t>causeweb.org</a:t>
-            </a:r>
-            <a:endParaRPr lang="en-US" sz="1000" dirty="0">
-              <a:solidFill>
-                <a:srgbClr val="333333"/>
-              </a:solidFill>
-              <a:latin typeface="Helvetica Neue" panose="02000503000000020004" pitchFamily="2" charset="0"/>
-            </a:endParaRPr>
+              <a:t>eCOTS</a:t>
+            </a:r>
+            <a:r>
+              <a:rPr lang="en-US" sz="1000" dirty="0">
+                <a:solidFill>
+                  <a:srgbClr val="333333"/>
+                </a:solidFill>
+                <a:latin typeface="Helvetica Neue" panose="02000503000000020004" pitchFamily="2" charset="0"/>
+              </a:rPr>
+              <a:t> 2026</a:t>
+            </a:r>
           </a:p>
           <a:p>
             <a:pPr marL="171450" indent="-171450">
@@ -3418,14 +3429,20 @@
               <a:buChar char="•"/>
             </a:pPr>
             <a:r>
-              <a:rPr lang="en-US" sz="1000" dirty="0">
-                <a:solidFill>
-                  <a:srgbClr val="333333"/>
-                </a:solidFill>
-                <a:latin typeface="Helvetica Neue" panose="02000503000000020004" pitchFamily="2" charset="0"/>
-              </a:rPr>
-              <a:t>Talk to me! </a:t>
-            </a:r>
+              <a:rPr lang="en-US" sz="1000" dirty="0" err="1">
+                <a:solidFill>
+                  <a:srgbClr val="333333"/>
+                </a:solidFill>
+                <a:latin typeface="Helvetica Neue" panose="02000503000000020004" pitchFamily="2" charset="0"/>
+              </a:rPr>
+              <a:t>causeweb.org</a:t>
+            </a:r>
+            <a:endParaRPr lang="en-US" sz="1000" dirty="0">
+              <a:solidFill>
+                <a:srgbClr val="333333"/>
+              </a:solidFill>
+              <a:latin typeface="Helvetica Neue" panose="02000503000000020004" pitchFamily="2" charset="0"/>
+            </a:endParaRPr>
           </a:p>
         </p:txBody>
       </p:sp>
@@ -3457,7 +3474,7 @@
         </p:blipFill>
         <p:spPr>
           <a:xfrm>
-            <a:off x="111301" y="6302870"/>
+            <a:off x="-195" y="5783638"/>
             <a:ext cx="427382" cy="427382"/>
           </a:xfrm>
           <a:prstGeom prst="rect">
@@ -3944,7 +3961,7 @@
         </p:blipFill>
         <p:spPr>
           <a:xfrm>
-            <a:off x="5587368" y="2149849"/>
+            <a:off x="5751818" y="2149849"/>
             <a:ext cx="2686050" cy="2686050"/>
           </a:xfrm>
           <a:prstGeom prst="rect">
@@ -3980,8 +3997,8 @@
         </p:blipFill>
         <p:spPr>
           <a:xfrm>
-            <a:off x="58548" y="1714500"/>
-            <a:ext cx="4804920" cy="2770872"/>
+            <a:off x="296689" y="1407412"/>
+            <a:ext cx="4558768" cy="2628923"/>
           </a:xfrm>
           <a:prstGeom prst="rect">
             <a:avLst/>

</xml_diff>